<commit_message>
Final academic repositioning, gap/contributions added, and tone neutralized across all deliverables
</commit_message>
<xml_diff>
--- a/Final/presentation/presentation.pptx
+++ b/Final/presentation/presentation.pptx
@@ -3379,7 +3379,7 @@
                 </a:solidFill>
                 <a:latin typeface="Arial"/>
               </a:rPr>
-              <a:t> zer</a:t>
+              <a:t> a r</a:t>
             </a:r>
             <a:r>
               <a:rPr sz="2800">
@@ -3397,7 +3397,61 @@
                 </a:solidFill>
                 <a:latin typeface="Arial"/>
               </a:rPr>
-              <a:t>-</a:t>
+              <a:t>bus</a:t>
+            </a:r>
+            <a:r>
+              <a:rPr sz="2800">
+                <a:solidFill>
+                  <a:srgbClr val="323232"/>
+                </a:solidFill>
+                <a:latin typeface="Arial"/>
+              </a:rPr>
+              <a:t>t</a:t>
+            </a:r>
+            <a:r>
+              <a:rPr sz="2800">
+                <a:solidFill>
+                  <a:srgbClr val="323232"/>
+                </a:solidFill>
+                <a:latin typeface="Arial"/>
+              </a:rPr>
+              <a:t> appr</a:t>
+            </a:r>
+            <a:r>
+              <a:rPr sz="2800">
+                <a:solidFill>
+                  <a:srgbClr val="323232"/>
+                </a:solidFill>
+                <a:latin typeface="Arial"/>
+              </a:rPr>
+              <a:t>o</a:t>
+            </a:r>
+            <a:r>
+              <a:rPr sz="2800">
+                <a:solidFill>
+                  <a:srgbClr val="323232"/>
+                </a:solidFill>
+                <a:latin typeface="Arial"/>
+              </a:rPr>
+              <a:t>a</a:t>
+            </a:r>
+            <a:r>
+              <a:rPr sz="2800">
+                <a:solidFill>
+                  <a:srgbClr val="323232"/>
+                </a:solidFill>
+                <a:latin typeface="Arial"/>
+              </a:rPr>
+              <a:t>c</a:t>
+            </a:r>
+            <a:r>
+              <a:rPr sz="2800">
+                <a:solidFill>
+                  <a:srgbClr val="323232"/>
+                </a:solidFill>
+                <a:latin typeface="Arial"/>
+              </a:rPr>
+              <a:t>h </a:t>
             </a:r>
             <a:r>
               <a:rPr sz="2800">
@@ -3415,43 +3469,7 @@
                 </a:solidFill>
                 <a:latin typeface="Arial"/>
               </a:rPr>
-              <a:t>leran</a:t>
-            </a:r>
-            <a:r>
-              <a:rPr sz="2800">
-                <a:solidFill>
-                  <a:srgbClr val="323232"/>
-                </a:solidFill>
-                <a:latin typeface="Arial"/>
-              </a:rPr>
-              <a:t>c</a:t>
-            </a:r>
-            <a:r>
-              <a:rPr sz="2800">
-                <a:solidFill>
-                  <a:srgbClr val="323232"/>
-                </a:solidFill>
-                <a:latin typeface="Arial"/>
-              </a:rPr>
-              <a:t>e f</a:t>
-            </a:r>
-            <a:r>
-              <a:rPr sz="2800">
-                <a:solidFill>
-                  <a:srgbClr val="323232"/>
-                </a:solidFill>
-                <a:latin typeface="Arial"/>
-              </a:rPr>
-              <a:t>o</a:t>
-            </a:r>
-            <a:r>
-              <a:rPr sz="2800">
-                <a:solidFill>
-                  <a:srgbClr val="323232"/>
-                </a:solidFill>
-                <a:latin typeface="Arial"/>
-              </a:rPr>
-              <a:t>r </a:t>
+              <a:t> </a:t>
             </a:r>
             <a:r>
               <a:rPr sz="2800">
@@ -5503,7 +5521,7 @@
               </a:defRPr>
             </a:pPr>
             <a:r>
-              <a:t>2. Methodology: Modular RAG Pipeline</a:t>
+              <a:t>3. Methodology: Modular RAG Pipeline</a:t>
             </a:r>
           </a:p>
         </p:txBody>
@@ -6216,7 +6234,7 @@
               </a:defRPr>
             </a:pPr>
             <a:r>
-              <a:t>3. Mathematical Foundations</a:t>
+              <a:t>4. Mathematical Foundations</a:t>
             </a:r>
           </a:p>
         </p:txBody>
@@ -7625,7 +7643,7 @@
               </a:defRPr>
             </a:pPr>
             <a:r>
-              <a:t>4. The Hybrid Perception Strategy</a:t>
+              <a:t>5. The Hybrid Perception Strategy</a:t>
             </a:r>
           </a:p>
         </p:txBody>
@@ -8358,7 +8376,7 @@
               </a:defRPr>
             </a:pPr>
             <a:r>
-              <a:t>5. Experimental Results</a:t>
+              <a:t>6. Experimental Results</a:t>
             </a:r>
           </a:p>
         </p:txBody>
@@ -9131,43 +9149,25 @@
                 </a:solidFill>
                 <a:latin typeface="Arial"/>
               </a:rPr>
-              <a:t>es</a:t>
-            </a:r>
-            <a:r>
-              <a:rPr sz="2800">
-                <a:solidFill>
-                  <a:srgbClr val="323232"/>
-                </a:solidFill>
-                <a:latin typeface="Arial"/>
-              </a:rPr>
-              <a:t>t</a:t>
-            </a:r>
-            <a:r>
-              <a:rPr sz="2800">
-                <a:solidFill>
-                  <a:srgbClr val="323232"/>
-                </a:solidFill>
-                <a:latin typeface="Arial"/>
-              </a:rPr>
-              <a:t>r</a:t>
-            </a:r>
-            <a:r>
-              <a:rPr sz="2800">
-                <a:solidFill>
-                  <a:srgbClr val="323232"/>
-                </a:solidFill>
-                <a:latin typeface="Arial"/>
-              </a:rPr>
-              <a:t>o</a:t>
-            </a:r>
-            <a:r>
-              <a:rPr sz="2800">
-                <a:solidFill>
-                  <a:srgbClr val="323232"/>
-                </a:solidFill>
-                <a:latin typeface="Arial"/>
-              </a:rPr>
-              <a:t>ying seman</a:t>
+              <a:t>egra</a:t>
+            </a:r>
+            <a:r>
+              <a:rPr sz="2800">
+                <a:solidFill>
+                  <a:srgbClr val="323232"/>
+                </a:solidFill>
+                <a:latin typeface="Arial"/>
+              </a:rPr>
+              <a:t>d</a:t>
+            </a:r>
+            <a:r>
+              <a:rPr sz="2800">
+                <a:solidFill>
+                  <a:srgbClr val="323232"/>
+                </a:solidFill>
+                <a:latin typeface="Arial"/>
+              </a:rPr>
+              <a:t>ing seman</a:t>
             </a:r>
             <a:r>
               <a:rPr sz="2800">
@@ -9840,7 +9840,7 @@
               </a:defRPr>
             </a:pPr>
             <a:r>
-              <a:t>7. Key Findings &amp; System Robustness Conclusion</a:t>
+              <a:t>8. Conclusion, Limitations, and Future Work</a:t>
             </a:r>
           </a:p>
         </p:txBody>
@@ -9880,7 +9880,133 @@
                 </a:solidFill>
                 <a:latin typeface="Arial"/>
               </a:rPr>
-              <a:t>Hybri</a:t>
+              <a:t>C</a:t>
+            </a:r>
+            <a:r>
+              <a:rPr sz="2800">
+                <a:solidFill>
+                  <a:srgbClr val="323232"/>
+                </a:solidFill>
+                <a:latin typeface="Arial"/>
+              </a:rPr>
+              <a:t>o</a:t>
+            </a:r>
+            <a:r>
+              <a:rPr sz="2800">
+                <a:solidFill>
+                  <a:srgbClr val="323232"/>
+                </a:solidFill>
+                <a:latin typeface="Arial"/>
+              </a:rPr>
+              <a:t>n</a:t>
+            </a:r>
+            <a:r>
+              <a:rPr sz="2800">
+                <a:solidFill>
+                  <a:srgbClr val="323232"/>
+                </a:solidFill>
+                <a:latin typeface="Arial"/>
+              </a:rPr>
+              <a:t>c</a:t>
+            </a:r>
+            <a:r>
+              <a:rPr sz="2800">
+                <a:solidFill>
+                  <a:srgbClr val="323232"/>
+                </a:solidFill>
+                <a:latin typeface="Arial"/>
+              </a:rPr>
+              <a:t>lusi</a:t>
+            </a:r>
+            <a:r>
+              <a:rPr sz="2800">
+                <a:solidFill>
+                  <a:srgbClr val="323232"/>
+                </a:solidFill>
+                <a:latin typeface="Arial"/>
+              </a:rPr>
+              <a:t>o</a:t>
+            </a:r>
+            <a:r>
+              <a:rPr sz="2800">
+                <a:solidFill>
+                  <a:srgbClr val="323232"/>
+                </a:solidFill>
+                <a:latin typeface="Arial"/>
+              </a:rPr>
+              <a:t>n: Fusing li</a:t>
+            </a:r>
+            <a:r>
+              <a:rPr sz="2800">
+                <a:solidFill>
+                  <a:srgbClr val="323232"/>
+                </a:solidFill>
+                <a:latin typeface="Arial"/>
+              </a:rPr>
+              <a:t>t</a:t>
+            </a:r>
+            <a:r>
+              <a:rPr sz="2800">
+                <a:solidFill>
+                  <a:srgbClr val="323232"/>
+                </a:solidFill>
+                <a:latin typeface="Arial"/>
+              </a:rPr>
+              <a:t>eral </a:t>
+            </a:r>
+            <a:r>
+              <a:rPr sz="2800">
+                <a:solidFill>
+                  <a:srgbClr val="323232"/>
+                </a:solidFill>
+                <a:latin typeface="Arial"/>
+              </a:rPr>
+              <a:t>c</a:t>
+            </a:r>
+            <a:r>
+              <a:rPr sz="2800">
+                <a:solidFill>
+                  <a:srgbClr val="323232"/>
+                </a:solidFill>
+                <a:latin typeface="Arial"/>
+              </a:rPr>
+              <a:t>hara</a:t>
+            </a:r>
+            <a:r>
+              <a:rPr sz="2800">
+                <a:solidFill>
+                  <a:srgbClr val="323232"/>
+                </a:solidFill>
+                <a:latin typeface="Arial"/>
+              </a:rPr>
+              <a:t>ct</a:t>
+            </a:r>
+            <a:r>
+              <a:rPr sz="2800">
+                <a:solidFill>
+                  <a:srgbClr val="323232"/>
+                </a:solidFill>
+                <a:latin typeface="Arial"/>
+              </a:rPr>
+              <a:t>er gr</a:t>
+            </a:r>
+            <a:r>
+              <a:rPr sz="2800">
+                <a:solidFill>
+                  <a:srgbClr val="323232"/>
+                </a:solidFill>
+                <a:latin typeface="Arial"/>
+              </a:rPr>
+              <a:t>o</a:t>
+            </a:r>
+            <a:r>
+              <a:rPr sz="2800">
+                <a:solidFill>
+                  <a:srgbClr val="323232"/>
+                </a:solidFill>
+                <a:latin typeface="Arial"/>
+              </a:rPr>
+              <a:t>un</a:t>
             </a:r>
             <a:r>
               <a:rPr sz="2800">
@@ -9898,7 +10024,43 @@
                 </a:solidFill>
                 <a:latin typeface="Arial"/>
               </a:rPr>
-              <a:t> Syn</a:t>
+              <a:t>ing wi</a:t>
+            </a:r>
+            <a:r>
+              <a:rPr sz="2800">
+                <a:solidFill>
+                  <a:srgbClr val="323232"/>
+                </a:solidFill>
+                <a:latin typeface="Arial"/>
+              </a:rPr>
+              <a:t>t</a:t>
+            </a:r>
+            <a:r>
+              <a:rPr sz="2800">
+                <a:solidFill>
+                  <a:srgbClr val="323232"/>
+                </a:solidFill>
+                <a:latin typeface="Arial"/>
+              </a:rPr>
+              <a:t>h seman</a:t>
+            </a:r>
+            <a:r>
+              <a:rPr sz="2800">
+                <a:solidFill>
+                  <a:srgbClr val="323232"/>
+                </a:solidFill>
+                <a:latin typeface="Arial"/>
+              </a:rPr>
+              <a:t>t</a:t>
+            </a:r>
+            <a:r>
+              <a:rPr sz="2800">
+                <a:solidFill>
+                  <a:srgbClr val="323232"/>
+                </a:solidFill>
+                <a:latin typeface="Arial"/>
+              </a:rPr>
+              <a:t>i</a:t>
             </a:r>
             <a:r>
               <a:rPr sz="2800">
@@ -9916,7 +10078,7 @@
                 </a:solidFill>
                 <a:latin typeface="Arial"/>
               </a:rPr>
-              <a:t>hr</a:t>
+              <a:t> lay</a:t>
             </a:r>
             <a:r>
               <a:rPr sz="2800">
@@ -9934,7 +10096,79 @@
                 </a:solidFill>
                 <a:latin typeface="Arial"/>
               </a:rPr>
-              <a:t>niza</a:t>
+              <a:t>u</a:t>
+            </a:r>
+            <a:r>
+              <a:rPr sz="2800">
+                <a:solidFill>
+                  <a:srgbClr val="323232"/>
+                </a:solidFill>
+                <a:latin typeface="Arial"/>
+              </a:rPr>
+              <a:t>t</a:t>
+            </a:r>
+            <a:r>
+              <a:rPr sz="2800">
+                <a:solidFill>
+                  <a:srgbClr val="323232"/>
+                </a:solidFill>
+                <a:latin typeface="Arial"/>
+              </a:rPr>
+              <a:t> awareness is essen</a:t>
+            </a:r>
+            <a:r>
+              <a:rPr sz="2800">
+                <a:solidFill>
+                  <a:srgbClr val="323232"/>
+                </a:solidFill>
+                <a:latin typeface="Arial"/>
+              </a:rPr>
+              <a:t>t</a:t>
+            </a:r>
+            <a:r>
+              <a:rPr sz="2800">
+                <a:solidFill>
+                  <a:srgbClr val="323232"/>
+                </a:solidFill>
+                <a:latin typeface="Arial"/>
+              </a:rPr>
+              <a:t>ial f</a:t>
+            </a:r>
+            <a:r>
+              <a:rPr sz="2800">
+                <a:solidFill>
+                  <a:srgbClr val="323232"/>
+                </a:solidFill>
+                <a:latin typeface="Arial"/>
+              </a:rPr>
+              <a:t>o</a:t>
+            </a:r>
+            <a:r>
+              <a:rPr sz="2800">
+                <a:solidFill>
+                  <a:srgbClr val="323232"/>
+                </a:solidFill>
+                <a:latin typeface="Arial"/>
+              </a:rPr>
+              <a:t>r suppressing res</a:t>
+            </a:r>
+            <a:r>
+              <a:rPr sz="2800">
+                <a:solidFill>
+                  <a:srgbClr val="323232"/>
+                </a:solidFill>
+                <a:latin typeface="Arial"/>
+              </a:rPr>
+              <a:t>o</a:t>
+            </a:r>
+            <a:r>
+              <a:rPr sz="2800">
+                <a:solidFill>
+                  <a:srgbClr val="323232"/>
+                </a:solidFill>
+                <a:latin typeface="Arial"/>
+              </a:rPr>
+              <a:t>lu</a:t>
             </a:r>
             <a:r>
               <a:rPr sz="2800">
@@ -9970,25 +10204,7 @@
                 </a:solidFill>
                 <a:latin typeface="Arial"/>
               </a:rPr>
-              <a:t>n as </a:t>
-            </a:r>
-            <a:r>
-              <a:rPr sz="2800">
-                <a:solidFill>
-                  <a:srgbClr val="323232"/>
-                </a:solidFill>
-                <a:latin typeface="Arial"/>
-              </a:rPr>
-              <a:t>t</a:t>
-            </a:r>
-            <a:r>
-              <a:rPr sz="2800">
-                <a:solidFill>
-                  <a:srgbClr val="323232"/>
-                </a:solidFill>
-                <a:latin typeface="Arial"/>
-              </a:rPr>
-              <a:t>he G</a:t>
+              <a:t>n-l</a:t>
             </a:r>
             <a:r>
               <a:rPr sz="2800">
@@ -10006,97 +10222,7 @@
                 </a:solidFill>
                 <a:latin typeface="Arial"/>
               </a:rPr>
-              <a:t>l</a:t>
-            </a:r>
-            <a:r>
-              <a:rPr sz="2800">
-                <a:solidFill>
-                  <a:srgbClr val="323232"/>
-                </a:solidFill>
-                <a:latin typeface="Arial"/>
-              </a:rPr>
-              <a:t>d</a:t>
-            </a:r>
-            <a:r>
-              <a:rPr sz="2800">
-                <a:solidFill>
-                  <a:srgbClr val="323232"/>
-                </a:solidFill>
-                <a:latin typeface="Arial"/>
-              </a:rPr>
-              <a:t> S</a:t>
-            </a:r>
-            <a:r>
-              <a:rPr sz="2800">
-                <a:solidFill>
-                  <a:srgbClr val="323232"/>
-                </a:solidFill>
-                <a:latin typeface="Arial"/>
-              </a:rPr>
-              <a:t>t</a:t>
-            </a:r>
-            <a:r>
-              <a:rPr sz="2800">
-                <a:solidFill>
-                  <a:srgbClr val="323232"/>
-                </a:solidFill>
-                <a:latin typeface="Arial"/>
-              </a:rPr>
-              <a:t>an</a:t>
-            </a:r>
-            <a:r>
-              <a:rPr sz="2800">
-                <a:solidFill>
-                  <a:srgbClr val="323232"/>
-                </a:solidFill>
-                <a:latin typeface="Arial"/>
-              </a:rPr>
-              <a:t>d</a:t>
-            </a:r>
-            <a:r>
-              <a:rPr sz="2800">
-                <a:solidFill>
-                  <a:srgbClr val="323232"/>
-                </a:solidFill>
-                <a:latin typeface="Arial"/>
-              </a:rPr>
-              <a:t>ar</a:t>
-            </a:r>
-            <a:r>
-              <a:rPr sz="2800">
-                <a:solidFill>
-                  <a:srgbClr val="323232"/>
-                </a:solidFill>
-                <a:latin typeface="Arial"/>
-              </a:rPr>
-              <a:t>d</a:t>
-            </a:r>
-            <a:r>
-              <a:rPr sz="2800">
-                <a:solidFill>
-                  <a:srgbClr val="323232"/>
-                </a:solidFill>
-                <a:latin typeface="Arial"/>
-              </a:rPr>
-              <a:t>: Fusing li</a:t>
-            </a:r>
-            <a:r>
-              <a:rPr sz="2800">
-                <a:solidFill>
-                  <a:srgbClr val="323232"/>
-                </a:solidFill>
-                <a:latin typeface="Arial"/>
-              </a:rPr>
-              <a:t>t</a:t>
-            </a:r>
-            <a:r>
-              <a:rPr sz="2800">
-                <a:solidFill>
-                  <a:srgbClr val="323232"/>
-                </a:solidFill>
-                <a:latin typeface="Arial"/>
-              </a:rPr>
-              <a:t>eral </a:t>
+              <a:t>ss hallu</a:t>
             </a:r>
             <a:r>
               <a:rPr sz="2800">
@@ -10114,25 +10240,25 @@
                 </a:solidFill>
                 <a:latin typeface="Arial"/>
               </a:rPr>
-              <a:t>hara</a:t>
-            </a:r>
-            <a:r>
-              <a:rPr sz="2800">
-                <a:solidFill>
-                  <a:srgbClr val="323232"/>
-                </a:solidFill>
-                <a:latin typeface="Arial"/>
-              </a:rPr>
-              <a:t>ct</a:t>
-            </a:r>
-            <a:r>
-              <a:rPr sz="2800">
-                <a:solidFill>
-                  <a:srgbClr val="323232"/>
-                </a:solidFill>
-                <a:latin typeface="Arial"/>
-              </a:rPr>
-              <a:t>er gr</a:t>
+              <a:t>ina</a:t>
+            </a:r>
+            <a:r>
+              <a:rPr sz="2800">
+                <a:solidFill>
+                  <a:srgbClr val="323232"/>
+                </a:solidFill>
+                <a:latin typeface="Arial"/>
+              </a:rPr>
+              <a:t>t</a:t>
+            </a:r>
+            <a:r>
+              <a:rPr sz="2800">
+                <a:solidFill>
+                  <a:srgbClr val="323232"/>
+                </a:solidFill>
+                <a:latin typeface="Arial"/>
+              </a:rPr>
+              <a:t>i</a:t>
             </a:r>
             <a:r>
               <a:rPr sz="2800">
@@ -10150,340 +10276,34 @@
                 </a:solidFill>
                 <a:latin typeface="Arial"/>
               </a:rPr>
-              <a:t>un</a:t>
-            </a:r>
-            <a:r>
-              <a:rPr sz="2800">
-                <a:solidFill>
-                  <a:srgbClr val="323232"/>
-                </a:solidFill>
-                <a:latin typeface="Arial"/>
-              </a:rPr>
-              <a:t>d</a:t>
-            </a:r>
-            <a:r>
-              <a:rPr sz="2800">
-                <a:solidFill>
-                  <a:srgbClr val="323232"/>
-                </a:solidFill>
-                <a:latin typeface="Arial"/>
-              </a:rPr>
-              <a:t>ing wi</a:t>
-            </a:r>
-            <a:r>
-              <a:rPr sz="2800">
-                <a:solidFill>
-                  <a:srgbClr val="323232"/>
-                </a:solidFill>
-                <a:latin typeface="Arial"/>
-              </a:rPr>
-              <a:t>t</a:t>
-            </a:r>
-            <a:r>
-              <a:rPr sz="2800">
-                <a:solidFill>
-                  <a:srgbClr val="323232"/>
-                </a:solidFill>
-                <a:latin typeface="Arial"/>
-              </a:rPr>
-              <a:t>h seman</a:t>
-            </a:r>
-            <a:r>
-              <a:rPr sz="2800">
-                <a:solidFill>
-                  <a:srgbClr val="323232"/>
-                </a:solidFill>
-                <a:latin typeface="Arial"/>
-              </a:rPr>
-              <a:t>t</a:t>
-            </a:r>
-            <a:r>
-              <a:rPr sz="2800">
-                <a:solidFill>
-                  <a:srgbClr val="323232"/>
-                </a:solidFill>
-                <a:latin typeface="Arial"/>
-              </a:rPr>
-              <a:t>i</a:t>
-            </a:r>
-            <a:r>
-              <a:rPr sz="2800">
-                <a:solidFill>
-                  <a:srgbClr val="323232"/>
-                </a:solidFill>
-                <a:latin typeface="Arial"/>
-              </a:rPr>
-              <a:t>c</a:t>
-            </a:r>
-            <a:r>
-              <a:rPr sz="2800">
-                <a:solidFill>
-                  <a:srgbClr val="323232"/>
-                </a:solidFill>
-                <a:latin typeface="Arial"/>
-              </a:rPr>
-              <a:t> lay</a:t>
-            </a:r>
-            <a:r>
-              <a:rPr sz="2800">
-                <a:solidFill>
-                  <a:srgbClr val="323232"/>
-                </a:solidFill>
-                <a:latin typeface="Arial"/>
-              </a:rPr>
-              <a:t>o</a:t>
-            </a:r>
-            <a:r>
-              <a:rPr sz="2800">
-                <a:solidFill>
-                  <a:srgbClr val="323232"/>
-                </a:solidFill>
-                <a:latin typeface="Arial"/>
-              </a:rPr>
-              <a:t>u</a:t>
-            </a:r>
-            <a:r>
-              <a:rPr sz="2800">
-                <a:solidFill>
-                  <a:srgbClr val="323232"/>
-                </a:solidFill>
-                <a:latin typeface="Arial"/>
-              </a:rPr>
-              <a:t>t</a:t>
-            </a:r>
-            <a:r>
-              <a:rPr sz="2800">
-                <a:solidFill>
-                  <a:srgbClr val="323232"/>
-                </a:solidFill>
-                <a:latin typeface="Arial"/>
-              </a:rPr>
-              <a:t> awareness is essen</a:t>
-            </a:r>
-            <a:r>
-              <a:rPr sz="2800">
-                <a:solidFill>
-                  <a:srgbClr val="323232"/>
-                </a:solidFill>
-                <a:latin typeface="Arial"/>
-              </a:rPr>
-              <a:t>t</a:t>
-            </a:r>
-            <a:r>
-              <a:rPr sz="2800">
-                <a:solidFill>
-                  <a:srgbClr val="323232"/>
-                </a:solidFill>
-                <a:latin typeface="Arial"/>
-              </a:rPr>
-              <a:t>ial f</a:t>
-            </a:r>
-            <a:r>
-              <a:rPr sz="2800">
-                <a:solidFill>
-                  <a:srgbClr val="323232"/>
-                </a:solidFill>
-                <a:latin typeface="Arial"/>
-              </a:rPr>
-              <a:t>o</a:t>
-            </a:r>
-            <a:r>
-              <a:rPr sz="2800">
-                <a:solidFill>
-                  <a:srgbClr val="323232"/>
-                </a:solidFill>
-                <a:latin typeface="Arial"/>
-              </a:rPr>
-              <a:t>r suppressing res</a:t>
-            </a:r>
-            <a:r>
-              <a:rPr sz="2800">
-                <a:solidFill>
-                  <a:srgbClr val="323232"/>
-                </a:solidFill>
-                <a:latin typeface="Arial"/>
-              </a:rPr>
-              <a:t>o</a:t>
-            </a:r>
-            <a:r>
-              <a:rPr sz="2800">
-                <a:solidFill>
-                  <a:srgbClr val="323232"/>
-                </a:solidFill>
-                <a:latin typeface="Arial"/>
-              </a:rPr>
-              <a:t>lu</a:t>
-            </a:r>
-            <a:r>
-              <a:rPr sz="2800">
-                <a:solidFill>
-                  <a:srgbClr val="323232"/>
-                </a:solidFill>
-                <a:latin typeface="Arial"/>
-              </a:rPr>
-              <a:t>t</a:t>
-            </a:r>
-            <a:r>
-              <a:rPr sz="2800">
-                <a:solidFill>
-                  <a:srgbClr val="323232"/>
-                </a:solidFill>
-                <a:latin typeface="Arial"/>
-              </a:rPr>
-              <a:t>i</a:t>
-            </a:r>
-            <a:r>
-              <a:rPr sz="2800">
-                <a:solidFill>
-                  <a:srgbClr val="323232"/>
-                </a:solidFill>
-                <a:latin typeface="Arial"/>
-              </a:rPr>
-              <a:t>o</a:t>
-            </a:r>
-            <a:r>
-              <a:rPr sz="2800">
-                <a:solidFill>
-                  <a:srgbClr val="323232"/>
-                </a:solidFill>
-                <a:latin typeface="Arial"/>
-              </a:rPr>
-              <a:t>n-l</a:t>
-            </a:r>
-            <a:r>
-              <a:rPr sz="2800">
-                <a:solidFill>
-                  <a:srgbClr val="323232"/>
-                </a:solidFill>
-                <a:latin typeface="Arial"/>
-              </a:rPr>
-              <a:t>o</a:t>
-            </a:r>
-            <a:r>
-              <a:rPr sz="2800">
-                <a:solidFill>
-                  <a:srgbClr val="323232"/>
-                </a:solidFill>
-                <a:latin typeface="Arial"/>
-              </a:rPr>
-              <a:t>ss hallu</a:t>
-            </a:r>
-            <a:r>
-              <a:rPr sz="2800">
-                <a:solidFill>
-                  <a:srgbClr val="323232"/>
-                </a:solidFill>
-                <a:latin typeface="Arial"/>
-              </a:rPr>
-              <a:t>c</a:t>
-            </a:r>
-            <a:r>
-              <a:rPr sz="2800">
-                <a:solidFill>
-                  <a:srgbClr val="323232"/>
-                </a:solidFill>
-                <a:latin typeface="Arial"/>
-              </a:rPr>
-              <a:t>ina</a:t>
-            </a:r>
-            <a:r>
-              <a:rPr sz="2800">
-                <a:solidFill>
-                  <a:srgbClr val="323232"/>
-                </a:solidFill>
-                <a:latin typeface="Arial"/>
-              </a:rPr>
-              <a:t>t</a:t>
-            </a:r>
-            <a:r>
-              <a:rPr sz="2800">
-                <a:solidFill>
-                  <a:srgbClr val="323232"/>
-                </a:solidFill>
-                <a:latin typeface="Arial"/>
-              </a:rPr>
-              <a:t>i</a:t>
-            </a:r>
-            <a:r>
-              <a:rPr sz="2800">
-                <a:solidFill>
-                  <a:srgbClr val="323232"/>
-                </a:solidFill>
-                <a:latin typeface="Arial"/>
-              </a:rPr>
-              <a:t>o</a:t>
-            </a:r>
-            <a:r>
-              <a:rPr sz="2800">
-                <a:solidFill>
-                  <a:srgbClr val="323232"/>
-                </a:solidFill>
-                <a:latin typeface="Arial"/>
-              </a:rPr>
-              <a:t>ns in missi</a:t>
-            </a:r>
-            <a:r>
-              <a:rPr sz="2800">
-                <a:solidFill>
-                  <a:srgbClr val="323232"/>
-                </a:solidFill>
-                <a:latin typeface="Arial"/>
-              </a:rPr>
-              <a:t>o</a:t>
-            </a:r>
-            <a:r>
-              <a:rPr sz="2800">
-                <a:solidFill>
-                  <a:srgbClr val="323232"/>
-                </a:solidFill>
-                <a:latin typeface="Arial"/>
-              </a:rPr>
-              <a:t>n-</a:t>
-            </a:r>
-            <a:r>
-              <a:rPr sz="2800">
-                <a:solidFill>
-                  <a:srgbClr val="323232"/>
-                </a:solidFill>
-                <a:latin typeface="Arial"/>
-              </a:rPr>
-              <a:t>c</a:t>
-            </a:r>
-            <a:r>
-              <a:rPr sz="2800">
-                <a:solidFill>
-                  <a:srgbClr val="323232"/>
-                </a:solidFill>
-                <a:latin typeface="Arial"/>
-              </a:rPr>
-              <a:t>ri</a:t>
-            </a:r>
-            <a:r>
-              <a:rPr sz="2800">
-                <a:solidFill>
-                  <a:srgbClr val="323232"/>
-                </a:solidFill>
-                <a:latin typeface="Arial"/>
-              </a:rPr>
-              <a:t>t</a:t>
-            </a:r>
-            <a:r>
-              <a:rPr sz="2800">
-                <a:solidFill>
-                  <a:srgbClr val="323232"/>
-                </a:solidFill>
-                <a:latin typeface="Arial"/>
-              </a:rPr>
-              <a:t>i</a:t>
-            </a:r>
-            <a:r>
-              <a:rPr sz="2800">
-                <a:solidFill>
-                  <a:srgbClr val="323232"/>
-                </a:solidFill>
-                <a:latin typeface="Arial"/>
-              </a:rPr>
-              <a:t>c</a:t>
+              <a:t>ns in mul</a:t>
+            </a:r>
+            <a:r>
+              <a:rPr sz="2800">
+                <a:solidFill>
+                  <a:srgbClr val="323232"/>
+                </a:solidFill>
+                <a:latin typeface="Arial"/>
+              </a:rPr>
+              <a:t>t</a:t>
+            </a:r>
+            <a:r>
+              <a:rPr sz="2800">
+                <a:solidFill>
+                  <a:srgbClr val="323232"/>
+                </a:solidFill>
+                <a:latin typeface="Arial"/>
+              </a:rPr>
+              <a:t>im</a:t>
+            </a:r>
+            <a:r>
+              <a:rPr sz="2800">
+                <a:solidFill>
+                  <a:srgbClr val="323232"/>
+                </a:solidFill>
+                <a:latin typeface="Arial"/>
+              </a:rPr>
+              <a:t>od</a:t>
             </a:r>
             <a:r>
               <a:rPr sz="2800">
@@ -10526,7 +10346,7 @@
                 </a:solidFill>
                 <a:latin typeface="Arial"/>
               </a:rPr>
-              <a:t>VLM Limi</a:t>
+              <a:t>Limi</a:t>
             </a:r>
             <a:r>
               <a:rPr sz="2800">
@@ -10580,16 +10400,106 @@
                 </a:solidFill>
                 <a:latin typeface="Arial"/>
               </a:rPr>
-              <a:t>ns: While s</a:t>
-            </a:r>
-            <a:r>
-              <a:rPr sz="2800">
-                <a:solidFill>
-                  <a:srgbClr val="323232"/>
-                </a:solidFill>
-                <a:latin typeface="Arial"/>
-              </a:rPr>
-              <a:t>t</a:t>
+              <a:t>ns: The Hybri</a:t>
+            </a:r>
+            <a:r>
+              <a:rPr sz="2800">
+                <a:solidFill>
+                  <a:srgbClr val="323232"/>
+                </a:solidFill>
+                <a:latin typeface="Arial"/>
+              </a:rPr>
+              <a:t>d</a:t>
+            </a:r>
+            <a:r>
+              <a:rPr sz="2800">
+                <a:solidFill>
+                  <a:srgbClr val="323232"/>
+                </a:solidFill>
+                <a:latin typeface="Arial"/>
+              </a:rPr>
+              <a:t> ar</a:t>
+            </a:r>
+            <a:r>
+              <a:rPr sz="2800">
+                <a:solidFill>
+                  <a:srgbClr val="323232"/>
+                </a:solidFill>
+                <a:latin typeface="Arial"/>
+              </a:rPr>
+              <a:t>c</a:t>
+            </a:r>
+            <a:r>
+              <a:rPr sz="2800">
+                <a:solidFill>
+                  <a:srgbClr val="323232"/>
+                </a:solidFill>
+                <a:latin typeface="Arial"/>
+              </a:rPr>
+              <a:t>hi</a:t>
+            </a:r>
+            <a:r>
+              <a:rPr sz="2800">
+                <a:solidFill>
+                  <a:srgbClr val="323232"/>
+                </a:solidFill>
+                <a:latin typeface="Arial"/>
+              </a:rPr>
+              <a:t>t</a:t>
+            </a:r>
+            <a:r>
+              <a:rPr sz="2800">
+                <a:solidFill>
+                  <a:srgbClr val="323232"/>
+                </a:solidFill>
+                <a:latin typeface="Arial"/>
+              </a:rPr>
+              <a:t>e</a:t>
+            </a:r>
+            <a:r>
+              <a:rPr sz="2800">
+                <a:solidFill>
+                  <a:srgbClr val="323232"/>
+                </a:solidFill>
+                <a:latin typeface="Arial"/>
+              </a:rPr>
+              <a:t>ct</a:t>
+            </a:r>
+            <a:r>
+              <a:rPr sz="2800">
+                <a:solidFill>
+                  <a:srgbClr val="323232"/>
+                </a:solidFill>
+                <a:latin typeface="Arial"/>
+              </a:rPr>
+              <a:t>ure exhibi</a:t>
+            </a:r>
+            <a:r>
+              <a:rPr sz="2800">
+                <a:solidFill>
+                  <a:srgbClr val="323232"/>
+                </a:solidFill>
+                <a:latin typeface="Arial"/>
+              </a:rPr>
+              <a:t>t</a:t>
+            </a:r>
+            <a:r>
+              <a:rPr sz="2800">
+                <a:solidFill>
+                  <a:srgbClr val="323232"/>
+                </a:solidFill>
+                <a:latin typeface="Arial"/>
+              </a:rPr>
+              <a:t>s signifi</a:t>
+            </a:r>
+            <a:r>
+              <a:rPr sz="2800">
+                <a:solidFill>
+                  <a:srgbClr val="323232"/>
+                </a:solidFill>
+                <a:latin typeface="Arial"/>
+              </a:rPr>
+              <a:t>c</a:t>
             </a:r>
             <a:r>
               <a:rPr sz="2800">
@@ -10607,6 +10517,114 @@
                 </a:solidFill>
                 <a:latin typeface="Arial"/>
               </a:rPr>
+              <a:t>t</a:t>
+            </a:r>
+            <a:r>
+              <a:rPr sz="2800">
+                <a:solidFill>
+                  <a:srgbClr val="323232"/>
+                </a:solidFill>
+                <a:latin typeface="Arial"/>
+              </a:rPr>
+              <a:t> </a:t>
+            </a:r>
+            <a:r>
+              <a:rPr sz="2800">
+                <a:solidFill>
+                  <a:srgbClr val="323232"/>
+                </a:solidFill>
+                <a:latin typeface="Arial"/>
+              </a:rPr>
+              <a:t>co</a:t>
+            </a:r>
+            <a:r>
+              <a:rPr sz="2800">
+                <a:solidFill>
+                  <a:srgbClr val="323232"/>
+                </a:solidFill>
+                <a:latin typeface="Arial"/>
+              </a:rPr>
+              <a:t>mpu</a:t>
+            </a:r>
+            <a:r>
+              <a:rPr sz="2800">
+                <a:solidFill>
+                  <a:srgbClr val="323232"/>
+                </a:solidFill>
+                <a:latin typeface="Arial"/>
+              </a:rPr>
+              <a:t>t</a:t>
+            </a:r>
+            <a:r>
+              <a:rPr sz="2800">
+                <a:solidFill>
+                  <a:srgbClr val="323232"/>
+                </a:solidFill>
+                <a:latin typeface="Arial"/>
+              </a:rPr>
+              <a:t>a</a:t>
+            </a:r>
+            <a:r>
+              <a:rPr sz="2800">
+                <a:solidFill>
+                  <a:srgbClr val="323232"/>
+                </a:solidFill>
+                <a:latin typeface="Arial"/>
+              </a:rPr>
+              <a:t>t</a:t>
+            </a:r>
+            <a:r>
+              <a:rPr sz="2800">
+                <a:solidFill>
+                  <a:srgbClr val="323232"/>
+                </a:solidFill>
+                <a:latin typeface="Arial"/>
+              </a:rPr>
+              <a:t>i</a:t>
+            </a:r>
+            <a:r>
+              <a:rPr sz="2800">
+                <a:solidFill>
+                  <a:srgbClr val="323232"/>
+                </a:solidFill>
+                <a:latin typeface="Arial"/>
+              </a:rPr>
+              <a:t>o</a:t>
+            </a:r>
+            <a:r>
+              <a:rPr sz="2800">
+                <a:solidFill>
+                  <a:srgbClr val="323232"/>
+                </a:solidFill>
+                <a:latin typeface="Arial"/>
+              </a:rPr>
+              <a:t>nal </a:t>
+            </a:r>
+            <a:r>
+              <a:rPr sz="2800">
+                <a:solidFill>
+                  <a:srgbClr val="323232"/>
+                </a:solidFill>
+                <a:latin typeface="Arial"/>
+              </a:rPr>
+              <a:t>o</a:t>
+            </a:r>
+            <a:r>
+              <a:rPr sz="2800">
+                <a:solidFill>
+                  <a:srgbClr val="323232"/>
+                </a:solidFill>
+                <a:latin typeface="Arial"/>
+              </a:rPr>
+              <a:t>verhea</a:t>
+            </a:r>
+            <a:r>
+              <a:rPr sz="2800">
+                <a:solidFill>
+                  <a:srgbClr val="323232"/>
+                </a:solidFill>
+                <a:latin typeface="Arial"/>
+              </a:rPr>
               <a:t>d</a:t>
             </a:r>
             <a:r>
@@ -10616,7 +10634,133 @@
                 </a:solidFill>
                 <a:latin typeface="Arial"/>
               </a:rPr>
-              <a:t>al</a:t>
+              <a:t>, an</a:t>
+            </a:r>
+            <a:r>
+              <a:rPr sz="2800">
+                <a:solidFill>
+                  <a:srgbClr val="323232"/>
+                </a:solidFill>
+                <a:latin typeface="Arial"/>
+              </a:rPr>
+              <a:t>d</a:t>
+            </a:r>
+            <a:r>
+              <a:rPr sz="2800">
+                <a:solidFill>
+                  <a:srgbClr val="323232"/>
+                </a:solidFill>
+                <a:latin typeface="Arial"/>
+              </a:rPr>
+              <a:t> experimen</a:t>
+            </a:r>
+            <a:r>
+              <a:rPr sz="2800">
+                <a:solidFill>
+                  <a:srgbClr val="323232"/>
+                </a:solidFill>
+                <a:latin typeface="Arial"/>
+              </a:rPr>
+              <a:t>t</a:t>
+            </a:r>
+            <a:r>
+              <a:rPr sz="2800">
+                <a:solidFill>
+                  <a:srgbClr val="323232"/>
+                </a:solidFill>
+                <a:latin typeface="Arial"/>
+              </a:rPr>
+              <a:t>s were </a:t>
+            </a:r>
+            <a:r>
+              <a:rPr sz="2800">
+                <a:solidFill>
+                  <a:srgbClr val="323232"/>
+                </a:solidFill>
+                <a:latin typeface="Arial"/>
+              </a:rPr>
+              <a:t>co</a:t>
+            </a:r>
+            <a:r>
+              <a:rPr sz="2800">
+                <a:solidFill>
+                  <a:srgbClr val="323232"/>
+                </a:solidFill>
+                <a:latin typeface="Arial"/>
+              </a:rPr>
+              <a:t>ns</a:t>
+            </a:r>
+            <a:r>
+              <a:rPr sz="2800">
+                <a:solidFill>
+                  <a:srgbClr val="323232"/>
+                </a:solidFill>
+                <a:latin typeface="Arial"/>
+              </a:rPr>
+              <a:t>t</a:t>
+            </a:r>
+            <a:r>
+              <a:rPr sz="2800">
+                <a:solidFill>
+                  <a:srgbClr val="323232"/>
+                </a:solidFill>
+                <a:latin typeface="Arial"/>
+              </a:rPr>
+              <a:t>raine</a:t>
+            </a:r>
+            <a:r>
+              <a:rPr sz="2800">
+                <a:solidFill>
+                  <a:srgbClr val="323232"/>
+                </a:solidFill>
+                <a:latin typeface="Arial"/>
+              </a:rPr>
+              <a:t>d</a:t>
+            </a:r>
+            <a:r>
+              <a:rPr sz="2800">
+                <a:solidFill>
+                  <a:srgbClr val="323232"/>
+                </a:solidFill>
+                <a:latin typeface="Arial"/>
+              </a:rPr>
+              <a:t> by CPU limi</a:t>
+            </a:r>
+            <a:r>
+              <a:rPr sz="2800">
+                <a:solidFill>
+                  <a:srgbClr val="323232"/>
+                </a:solidFill>
+                <a:latin typeface="Arial"/>
+              </a:rPr>
+              <a:t>t</a:t>
+            </a:r>
+            <a:r>
+              <a:rPr sz="2800">
+                <a:solidFill>
+                  <a:srgbClr val="323232"/>
+                </a:solidFill>
+                <a:latin typeface="Arial"/>
+              </a:rPr>
+              <a:t>a</a:t>
+            </a:r>
+            <a:r>
+              <a:rPr sz="2800">
+                <a:solidFill>
+                  <a:srgbClr val="323232"/>
+                </a:solidFill>
+                <a:latin typeface="Arial"/>
+              </a:rPr>
+              <a:t>t</a:t>
+            </a:r>
+            <a:r>
+              <a:rPr sz="2800">
+                <a:solidFill>
+                  <a:srgbClr val="323232"/>
+                </a:solidFill>
+                <a:latin typeface="Arial"/>
+              </a:rPr>
+              <a:t>i</a:t>
             </a:r>
             <a:r>
               <a:rPr sz="2800">
@@ -10634,7 +10778,7 @@
                 </a:solidFill>
                 <a:latin typeface="Arial"/>
               </a:rPr>
-              <a:t>ne VLMs </a:t>
+              <a:t>ns an</a:t>
             </a:r>
             <a:r>
               <a:rPr sz="2800">
@@ -10652,25 +10796,79 @@
                 </a:solidFill>
                 <a:latin typeface="Arial"/>
               </a:rPr>
-              <a:t>eliver high-</a:t>
-            </a:r>
-            <a:r>
-              <a:rPr sz="2800">
-                <a:solidFill>
-                  <a:srgbClr val="323232"/>
-                </a:solidFill>
-                <a:latin typeface="Arial"/>
-              </a:rPr>
-              <a:t>t</a:t>
-            </a:r>
-            <a:r>
-              <a:rPr sz="2800">
-                <a:solidFill>
-                  <a:srgbClr val="323232"/>
-                </a:solidFill>
-                <a:latin typeface="Arial"/>
-              </a:rPr>
-              <a:t>hr</a:t>
+              <a:t> a 50-</a:t>
+            </a:r>
+            <a:r>
+              <a:rPr sz="2800">
+                <a:solidFill>
+                  <a:srgbClr val="323232"/>
+                </a:solidFill>
+                <a:latin typeface="Arial"/>
+              </a:rPr>
+              <a:t>doc</a:t>
+            </a:r>
+            <a:r>
+              <a:rPr sz="2800">
+                <a:solidFill>
+                  <a:srgbClr val="323232"/>
+                </a:solidFill>
+                <a:latin typeface="Arial"/>
+              </a:rPr>
+              <a:t>umen</a:t>
+            </a:r>
+            <a:r>
+              <a:rPr sz="2800">
+                <a:solidFill>
+                  <a:srgbClr val="323232"/>
+                </a:solidFill>
+                <a:latin typeface="Arial"/>
+              </a:rPr>
+              <a:t>t</a:t>
+            </a:r>
+            <a:r>
+              <a:rPr sz="2800">
+                <a:solidFill>
+                  <a:srgbClr val="323232"/>
+                </a:solidFill>
+                <a:latin typeface="Arial"/>
+              </a:rPr>
+              <a:t> vali</a:t>
+            </a:r>
+            <a:r>
+              <a:rPr sz="2800">
+                <a:solidFill>
+                  <a:srgbClr val="323232"/>
+                </a:solidFill>
+                <a:latin typeface="Arial"/>
+              </a:rPr>
+              <a:t>d</a:t>
+            </a:r>
+            <a:r>
+              <a:rPr sz="2800">
+                <a:solidFill>
+                  <a:srgbClr val="323232"/>
+                </a:solidFill>
+                <a:latin typeface="Arial"/>
+              </a:rPr>
+              <a:t>a</a:t>
+            </a:r>
+            <a:r>
+              <a:rPr sz="2800">
+                <a:solidFill>
+                  <a:srgbClr val="323232"/>
+                </a:solidFill>
+                <a:latin typeface="Arial"/>
+              </a:rPr>
+              <a:t>t</a:t>
+            </a:r>
+            <a:r>
+              <a:rPr sz="2800">
+                <a:solidFill>
+                  <a:srgbClr val="323232"/>
+                </a:solidFill>
+                <a:latin typeface="Arial"/>
+              </a:rPr>
+              <a:t>i</a:t>
             </a:r>
             <a:r>
               <a:rPr sz="2800">
@@ -10688,259 +10886,7 @@
                 </a:solidFill>
                 <a:latin typeface="Arial"/>
               </a:rPr>
-              <a:t>ughpu</a:t>
-            </a:r>
-            <a:r>
-              <a:rPr sz="2800">
-                <a:solidFill>
-                  <a:srgbClr val="323232"/>
-                </a:solidFill>
-                <a:latin typeface="Arial"/>
-              </a:rPr>
-              <a:t>t</a:t>
-            </a:r>
-            <a:r>
-              <a:rPr sz="2800">
-                <a:solidFill>
-                  <a:srgbClr val="323232"/>
-                </a:solidFill>
-                <a:latin typeface="Arial"/>
-              </a:rPr>
-              <a:t>, </a:t>
-            </a:r>
-            <a:r>
-              <a:rPr sz="2800">
-                <a:solidFill>
-                  <a:srgbClr val="323232"/>
-                </a:solidFill>
-                <a:latin typeface="Arial"/>
-              </a:rPr>
-              <a:t>t</a:t>
-            </a:r>
-            <a:r>
-              <a:rPr sz="2800">
-                <a:solidFill>
-                  <a:srgbClr val="323232"/>
-                </a:solidFill>
-                <a:latin typeface="Arial"/>
-              </a:rPr>
-              <a:t>heir vulnerabili</a:t>
-            </a:r>
-            <a:r>
-              <a:rPr sz="2800">
-                <a:solidFill>
-                  <a:srgbClr val="323232"/>
-                </a:solidFill>
-                <a:latin typeface="Arial"/>
-              </a:rPr>
-              <a:t>t</a:t>
-            </a:r>
-            <a:r>
-              <a:rPr sz="2800">
-                <a:solidFill>
-                  <a:srgbClr val="323232"/>
-                </a:solidFill>
-                <a:latin typeface="Arial"/>
-              </a:rPr>
-              <a:t>y </a:t>
-            </a:r>
-            <a:r>
-              <a:rPr sz="2800">
-                <a:solidFill>
-                  <a:srgbClr val="323232"/>
-                </a:solidFill>
-                <a:latin typeface="Arial"/>
-              </a:rPr>
-              <a:t>to</a:t>
-            </a:r>
-            <a:r>
-              <a:rPr sz="2800">
-                <a:solidFill>
-                  <a:srgbClr val="323232"/>
-                </a:solidFill>
-                <a:latin typeface="Arial"/>
-              </a:rPr>
-              <a:t> res</a:t>
-            </a:r>
-            <a:r>
-              <a:rPr sz="2800">
-                <a:solidFill>
-                  <a:srgbClr val="323232"/>
-                </a:solidFill>
-                <a:latin typeface="Arial"/>
-              </a:rPr>
-              <a:t>o</a:t>
-            </a:r>
-            <a:r>
-              <a:rPr sz="2800">
-                <a:solidFill>
-                  <a:srgbClr val="323232"/>
-                </a:solidFill>
-                <a:latin typeface="Arial"/>
-              </a:rPr>
-              <a:t>lu</a:t>
-            </a:r>
-            <a:r>
-              <a:rPr sz="2800">
-                <a:solidFill>
-                  <a:srgbClr val="323232"/>
-                </a:solidFill>
-                <a:latin typeface="Arial"/>
-              </a:rPr>
-              <a:t>t</a:t>
-            </a:r>
-            <a:r>
-              <a:rPr sz="2800">
-                <a:solidFill>
-                  <a:srgbClr val="323232"/>
-                </a:solidFill>
-                <a:latin typeface="Arial"/>
-              </a:rPr>
-              <a:t>i</a:t>
-            </a:r>
-            <a:r>
-              <a:rPr sz="2800">
-                <a:solidFill>
-                  <a:srgbClr val="323232"/>
-                </a:solidFill>
-                <a:latin typeface="Arial"/>
-              </a:rPr>
-              <a:t>o</a:t>
-            </a:r>
-            <a:r>
-              <a:rPr sz="2800">
-                <a:solidFill>
-                  <a:srgbClr val="323232"/>
-                </a:solidFill>
-                <a:latin typeface="Arial"/>
-              </a:rPr>
-              <a:t>n-l</a:t>
-            </a:r>
-            <a:r>
-              <a:rPr sz="2800">
-                <a:solidFill>
-                  <a:srgbClr val="323232"/>
-                </a:solidFill>
-                <a:latin typeface="Arial"/>
-              </a:rPr>
-              <a:t>o</a:t>
-            </a:r>
-            <a:r>
-              <a:rPr sz="2800">
-                <a:solidFill>
-                  <a:srgbClr val="323232"/>
-                </a:solidFill>
-                <a:latin typeface="Arial"/>
-              </a:rPr>
-              <a:t>ss makes </a:t>
-            </a:r>
-            <a:r>
-              <a:rPr sz="2800">
-                <a:solidFill>
-                  <a:srgbClr val="323232"/>
-                </a:solidFill>
-                <a:latin typeface="Arial"/>
-              </a:rPr>
-              <a:t>t</a:t>
-            </a:r>
-            <a:r>
-              <a:rPr sz="2800">
-                <a:solidFill>
-                  <a:srgbClr val="323232"/>
-                </a:solidFill>
-                <a:latin typeface="Arial"/>
-              </a:rPr>
-              <a:t>hem s</a:t>
-            </a:r>
-            <a:r>
-              <a:rPr sz="2800">
-                <a:solidFill>
-                  <a:srgbClr val="323232"/>
-                </a:solidFill>
-                <a:latin typeface="Arial"/>
-              </a:rPr>
-              <a:t>t</a:t>
-            </a:r>
-            <a:r>
-              <a:rPr sz="2800">
-                <a:solidFill>
-                  <a:srgbClr val="323232"/>
-                </a:solidFill>
-                <a:latin typeface="Arial"/>
-              </a:rPr>
-              <a:t>ru</a:t>
-            </a:r>
-            <a:r>
-              <a:rPr sz="2800">
-                <a:solidFill>
-                  <a:srgbClr val="323232"/>
-                </a:solidFill>
-                <a:latin typeface="Arial"/>
-              </a:rPr>
-              <a:t>ct</a:t>
-            </a:r>
-            <a:r>
-              <a:rPr sz="2800">
-                <a:solidFill>
-                  <a:srgbClr val="323232"/>
-                </a:solidFill>
-                <a:latin typeface="Arial"/>
-              </a:rPr>
-              <a:t>urally unreliable f</a:t>
-            </a:r>
-            <a:r>
-              <a:rPr sz="2800">
-                <a:solidFill>
-                  <a:srgbClr val="323232"/>
-                </a:solidFill>
-                <a:latin typeface="Arial"/>
-              </a:rPr>
-              <a:t>o</a:t>
-            </a:r>
-            <a:r>
-              <a:rPr sz="2800">
-                <a:solidFill>
-                  <a:srgbClr val="323232"/>
-                </a:solidFill>
-                <a:latin typeface="Arial"/>
-              </a:rPr>
-              <a:t>r exa</a:t>
-            </a:r>
-            <a:r>
-              <a:rPr sz="2800">
-                <a:solidFill>
-                  <a:srgbClr val="323232"/>
-                </a:solidFill>
-                <a:latin typeface="Arial"/>
-              </a:rPr>
-              <a:t>ct</a:t>
-            </a:r>
-            <a:r>
-              <a:rPr sz="2800">
-                <a:solidFill>
-                  <a:srgbClr val="323232"/>
-                </a:solidFill>
-                <a:latin typeface="Arial"/>
-              </a:rPr>
-              <a:t>-ma</a:t>
-            </a:r>
-            <a:r>
-              <a:rPr sz="2800">
-                <a:solidFill>
-                  <a:srgbClr val="323232"/>
-                </a:solidFill>
-                <a:latin typeface="Arial"/>
-              </a:rPr>
-              <a:t>tc</a:t>
-            </a:r>
-            <a:r>
-              <a:rPr sz="2800">
-                <a:solidFill>
-                  <a:srgbClr val="323232"/>
-                </a:solidFill>
-                <a:latin typeface="Arial"/>
-              </a:rPr>
-              <a:t>h finan</a:t>
+              <a:t>n s</a:t>
             </a:r>
             <a:r>
               <a:rPr sz="2800">
@@ -10958,43 +10904,7 @@
                 </a:solidFill>
                 <a:latin typeface="Arial"/>
               </a:rPr>
-              <a:t>ial pre</a:t>
-            </a:r>
-            <a:r>
-              <a:rPr sz="2800">
-                <a:solidFill>
-                  <a:srgbClr val="323232"/>
-                </a:solidFill>
-                <a:latin typeface="Arial"/>
-              </a:rPr>
-              <a:t>c</a:t>
-            </a:r>
-            <a:r>
-              <a:rPr sz="2800">
-                <a:solidFill>
-                  <a:srgbClr val="323232"/>
-                </a:solidFill>
-                <a:latin typeface="Arial"/>
-              </a:rPr>
-              <a:t>isi</a:t>
-            </a:r>
-            <a:r>
-              <a:rPr sz="2800">
-                <a:solidFill>
-                  <a:srgbClr val="323232"/>
-                </a:solidFill>
-                <a:latin typeface="Arial"/>
-              </a:rPr>
-              <a:t>o</a:t>
-            </a:r>
-            <a:r>
-              <a:rPr sz="2800">
-                <a:solidFill>
-                  <a:srgbClr val="323232"/>
-                </a:solidFill>
-                <a:latin typeface="Arial"/>
-              </a:rPr>
-              <a:t>n.</a:t>
+              <a:t>ale.</a:t>
             </a:r>
           </a:p>
           <a:p>
@@ -11010,7 +10920,295 @@
                 </a:solidFill>
                 <a:latin typeface="Arial"/>
               </a:rPr>
-              <a:t>Evalua</a:t>
+              <a:t/>
+            </a:r>
+            <a:r>
+              <a:rPr sz="2800" b="1">
+                <a:solidFill>
+                  <a:srgbClr val="1E3A8A"/>
+                </a:solidFill>
+                <a:latin typeface="Arial"/>
+              </a:rPr>
+              <a:t>B</a:t>
+            </a:r>
+            <a:r>
+              <a:rPr sz="2800">
+                <a:solidFill>
+                  <a:srgbClr val="323232"/>
+                </a:solidFill>
+                <a:latin typeface="Arial"/>
+              </a:rPr>
+              <a:t>en</a:t>
+            </a:r>
+            <a:r>
+              <a:rPr sz="2800">
+                <a:solidFill>
+                  <a:srgbClr val="323232"/>
+                </a:solidFill>
+                <a:latin typeface="Arial"/>
+              </a:rPr>
+              <a:t>c</a:t>
+            </a:r>
+            <a:r>
+              <a:rPr sz="2800">
+                <a:solidFill>
+                  <a:srgbClr val="323232"/>
+                </a:solidFill>
+                <a:latin typeface="Arial"/>
+              </a:rPr>
+              <a:t>hmark C</a:t>
+            </a:r>
+            <a:r>
+              <a:rPr sz="2800">
+                <a:solidFill>
+                  <a:srgbClr val="323232"/>
+                </a:solidFill>
+                <a:latin typeface="Arial"/>
+              </a:rPr>
+              <a:t>o</a:t>
+            </a:r>
+            <a:r>
+              <a:rPr sz="2800">
+                <a:solidFill>
+                  <a:srgbClr val="323232"/>
+                </a:solidFill>
+                <a:latin typeface="Arial"/>
+              </a:rPr>
+              <a:t>n</a:t>
+            </a:r>
+            <a:r>
+              <a:rPr sz="2800">
+                <a:solidFill>
+                  <a:srgbClr val="323232"/>
+                </a:solidFill>
+                <a:latin typeface="Arial"/>
+              </a:rPr>
+              <a:t>t</a:t>
+            </a:r>
+            <a:r>
+              <a:rPr sz="2800">
+                <a:solidFill>
+                  <a:srgbClr val="323232"/>
+                </a:solidFill>
+                <a:latin typeface="Arial"/>
+              </a:rPr>
+              <a:t>ex</a:t>
+            </a:r>
+            <a:r>
+              <a:rPr sz="2800">
+                <a:solidFill>
+                  <a:srgbClr val="323232"/>
+                </a:solidFill>
+                <a:latin typeface="Arial"/>
+              </a:rPr>
+              <a:t>t</a:t>
+            </a:r>
+            <a:r>
+              <a:rPr sz="2800">
+                <a:solidFill>
+                  <a:srgbClr val="323232"/>
+                </a:solidFill>
+                <a:latin typeface="Arial"/>
+              </a:rPr>
+              <a:t>: L</a:t>
+            </a:r>
+            <a:r>
+              <a:rPr sz="2800">
+                <a:solidFill>
+                  <a:srgbClr val="323232"/>
+                </a:solidFill>
+                <a:latin typeface="Arial"/>
+              </a:rPr>
+              <a:t>o</a:t>
+            </a:r>
+            <a:r>
+              <a:rPr sz="2800">
+                <a:solidFill>
+                  <a:srgbClr val="323232"/>
+                </a:solidFill>
+                <a:latin typeface="Arial"/>
+              </a:rPr>
+              <a:t>w abs</a:t>
+            </a:r>
+            <a:r>
+              <a:rPr sz="2800">
+                <a:solidFill>
+                  <a:srgbClr val="323232"/>
+                </a:solidFill>
+                <a:latin typeface="Arial"/>
+              </a:rPr>
+              <a:t>o</a:t>
+            </a:r>
+            <a:r>
+              <a:rPr sz="2800">
+                <a:solidFill>
+                  <a:srgbClr val="323232"/>
+                </a:solidFill>
+                <a:latin typeface="Arial"/>
+              </a:rPr>
+              <a:t>lu</a:t>
+            </a:r>
+            <a:r>
+              <a:rPr sz="2800">
+                <a:solidFill>
+                  <a:srgbClr val="323232"/>
+                </a:solidFill>
+                <a:latin typeface="Arial"/>
+              </a:rPr>
+              <a:t>t</a:t>
+            </a:r>
+            <a:r>
+              <a:rPr sz="2800">
+                <a:solidFill>
+                  <a:srgbClr val="323232"/>
+                </a:solidFill>
+                <a:latin typeface="Arial"/>
+              </a:rPr>
+              <a:t>e </a:t>
+            </a:r>
+            <a:r>
+              <a:rPr sz="2800" b="1">
+                <a:solidFill>
+                  <a:srgbClr val="1E3A8A"/>
+                </a:solidFill>
+                <a:latin typeface="Arial"/>
+              </a:rPr>
+              <a:t>A</a:t>
+            </a:r>
+            <a:r>
+              <a:rPr sz="2800">
+                <a:solidFill>
+                  <a:srgbClr val="323232"/>
+                </a:solidFill>
+                <a:latin typeface="Arial"/>
+              </a:rPr>
+              <a:t>NLS s</a:t>
+            </a:r>
+            <a:r>
+              <a:rPr sz="2800">
+                <a:solidFill>
+                  <a:srgbClr val="323232"/>
+                </a:solidFill>
+                <a:latin typeface="Arial"/>
+              </a:rPr>
+              <a:t>co</a:t>
+            </a:r>
+            <a:r>
+              <a:rPr sz="2800">
+                <a:solidFill>
+                  <a:srgbClr val="323232"/>
+                </a:solidFill>
+                <a:latin typeface="Arial"/>
+              </a:rPr>
+              <a:t>res refle</a:t>
+            </a:r>
+            <a:r>
+              <a:rPr sz="2800">
+                <a:solidFill>
+                  <a:srgbClr val="323232"/>
+                </a:solidFill>
+                <a:latin typeface="Arial"/>
+              </a:rPr>
+              <a:t>ct</a:t>
+            </a:r>
+            <a:r>
+              <a:rPr sz="2800">
+                <a:solidFill>
+                  <a:srgbClr val="323232"/>
+                </a:solidFill>
+                <a:latin typeface="Arial"/>
+              </a:rPr>
+              <a:t> </a:t>
+            </a:r>
+            <a:r>
+              <a:rPr sz="2800">
+                <a:solidFill>
+                  <a:srgbClr val="323232"/>
+                </a:solidFill>
+                <a:latin typeface="Arial"/>
+              </a:rPr>
+              <a:t>t</a:t>
+            </a:r>
+            <a:r>
+              <a:rPr sz="2800">
+                <a:solidFill>
+                  <a:srgbClr val="323232"/>
+                </a:solidFill>
+                <a:latin typeface="Arial"/>
+              </a:rPr>
+              <a:t>he s</a:t>
+            </a:r>
+            <a:r>
+              <a:rPr sz="2800">
+                <a:solidFill>
+                  <a:srgbClr val="323232"/>
+                </a:solidFill>
+                <a:latin typeface="Arial"/>
+              </a:rPr>
+              <a:t>t</a:t>
+            </a:r>
+            <a:r>
+              <a:rPr sz="2800">
+                <a:solidFill>
+                  <a:srgbClr val="323232"/>
+                </a:solidFill>
+                <a:latin typeface="Arial"/>
+              </a:rPr>
+              <a:t>ri</a:t>
+            </a:r>
+            <a:r>
+              <a:rPr sz="2800">
+                <a:solidFill>
+                  <a:srgbClr val="323232"/>
+                </a:solidFill>
+                <a:latin typeface="Arial"/>
+              </a:rPr>
+              <a:t>ct</a:t>
+            </a:r>
+            <a:r>
+              <a:rPr sz="2800">
+                <a:solidFill>
+                  <a:srgbClr val="323232"/>
+                </a:solidFill>
+                <a:latin typeface="Arial"/>
+              </a:rPr>
+              <a:t> zer</a:t>
+            </a:r>
+            <a:r>
+              <a:rPr sz="2800">
+                <a:solidFill>
+                  <a:srgbClr val="323232"/>
+                </a:solidFill>
+                <a:latin typeface="Arial"/>
+              </a:rPr>
+              <a:t>o</a:t>
+            </a:r>
+            <a:r>
+              <a:rPr sz="2800">
+                <a:solidFill>
+                  <a:srgbClr val="323232"/>
+                </a:solidFill>
+                <a:latin typeface="Arial"/>
+              </a:rPr>
+              <a:t>-sh</a:t>
+            </a:r>
+            <a:r>
+              <a:rPr sz="2800">
+                <a:solidFill>
+                  <a:srgbClr val="323232"/>
+                </a:solidFill>
+                <a:latin typeface="Arial"/>
+              </a:rPr>
+              <a:t>ot</a:t>
+            </a:r>
+            <a:r>
+              <a:rPr sz="2800">
+                <a:solidFill>
+                  <a:srgbClr val="323232"/>
+                </a:solidFill>
+                <a:latin typeface="Arial"/>
+              </a:rPr>
+              <a:t> evalua</a:t>
             </a:r>
             <a:r>
               <a:rPr sz="2800">
@@ -11046,25 +11244,25 @@
                 </a:solidFill>
                 <a:latin typeface="Arial"/>
               </a:rPr>
-              <a:t>n Impa</a:t>
-            </a:r>
-            <a:r>
-              <a:rPr sz="2800">
-                <a:solidFill>
-                  <a:srgbClr val="323232"/>
-                </a:solidFill>
-                <a:latin typeface="Arial"/>
-              </a:rPr>
-              <a:t>ct</a:t>
-            </a:r>
-            <a:r>
-              <a:rPr sz="2800">
-                <a:solidFill>
-                  <a:srgbClr val="323232"/>
-                </a:solidFill>
-                <a:latin typeface="Arial"/>
-              </a:rPr>
-              <a:t>: This framew</a:t>
+              <a:t>n pr</a:t>
+            </a:r>
+            <a:r>
+              <a:rPr sz="2800">
+                <a:solidFill>
+                  <a:srgbClr val="323232"/>
+                </a:solidFill>
+                <a:latin typeface="Arial"/>
+              </a:rPr>
+              <a:t>otoco</a:t>
+            </a:r>
+            <a:r>
+              <a:rPr sz="2800">
+                <a:solidFill>
+                  <a:srgbClr val="323232"/>
+                </a:solidFill>
+                <a:latin typeface="Arial"/>
+              </a:rPr>
+              <a:t>l </a:t>
             </a:r>
             <a:r>
               <a:rPr sz="2800">
@@ -11082,79 +11280,277 @@
                 </a:solidFill>
                 <a:latin typeface="Arial"/>
               </a:rPr>
-              <a:t>rk su</a:t>
-            </a:r>
-            <a:r>
-              <a:rPr sz="2800">
-                <a:solidFill>
-                  <a:srgbClr val="323232"/>
-                </a:solidFill>
-                <a:latin typeface="Arial"/>
-              </a:rPr>
-              <a:t>cc</a:t>
-            </a:r>
-            <a:r>
-              <a:rPr sz="2800">
-                <a:solidFill>
-                  <a:srgbClr val="323232"/>
-                </a:solidFill>
-                <a:latin typeface="Arial"/>
-              </a:rPr>
-              <a:t>essfully quan</a:t>
-            </a:r>
-            <a:r>
-              <a:rPr sz="2800">
-                <a:solidFill>
-                  <a:srgbClr val="323232"/>
-                </a:solidFill>
-                <a:latin typeface="Arial"/>
-              </a:rPr>
-              <a:t>t</a:t>
-            </a:r>
-            <a:r>
-              <a:rPr sz="2800">
-                <a:solidFill>
-                  <a:srgbClr val="323232"/>
-                </a:solidFill>
-                <a:latin typeface="Arial"/>
-              </a:rPr>
-              <a:t>ifies </a:t>
-            </a:r>
-            <a:r>
-              <a:rPr sz="2800">
-                <a:solidFill>
-                  <a:srgbClr val="323232"/>
-                </a:solidFill>
-                <a:latin typeface="Arial"/>
-              </a:rPr>
-              <a:t>t</a:t>
-            </a:r>
-            <a:r>
-              <a:rPr sz="2800">
-                <a:solidFill>
-                  <a:srgbClr val="323232"/>
-                </a:solidFill>
-                <a:latin typeface="Arial"/>
-              </a:rPr>
-              <a:t>he </a:t>
-            </a:r>
-            <a:r>
-              <a:rPr sz="2800">
-                <a:solidFill>
-                  <a:srgbClr val="323232"/>
-                </a:solidFill>
-                <a:latin typeface="Arial"/>
-              </a:rPr>
-              <a:t>t</a:t>
-            </a:r>
-            <a:r>
-              <a:rPr sz="2800">
-                <a:solidFill>
-                  <a:srgbClr val="323232"/>
-                </a:solidFill>
-                <a:latin typeface="Arial"/>
-              </a:rPr>
-              <a:t>ra</a:t>
+              <a:t>n high-</a:t>
+            </a:r>
+            <a:r>
+              <a:rPr sz="2800">
+                <a:solidFill>
+                  <a:srgbClr val="323232"/>
+                </a:solidFill>
+                <a:latin typeface="Arial"/>
+              </a:rPr>
+              <a:t>co</a:t>
+            </a:r>
+            <a:r>
+              <a:rPr sz="2800">
+                <a:solidFill>
+                  <a:srgbClr val="323232"/>
+                </a:solidFill>
+                <a:latin typeface="Arial"/>
+              </a:rPr>
+              <a:t>mplexi</a:t>
+            </a:r>
+            <a:r>
+              <a:rPr sz="2800">
+                <a:solidFill>
+                  <a:srgbClr val="323232"/>
+                </a:solidFill>
+                <a:latin typeface="Arial"/>
+              </a:rPr>
+              <a:t>t</a:t>
+            </a:r>
+            <a:r>
+              <a:rPr sz="2800">
+                <a:solidFill>
+                  <a:srgbClr val="323232"/>
+                </a:solidFill>
+                <a:latin typeface="Arial"/>
+              </a:rPr>
+              <a:t>y lay</a:t>
+            </a:r>
+            <a:r>
+              <a:rPr sz="2800">
+                <a:solidFill>
+                  <a:srgbClr val="323232"/>
+                </a:solidFill>
+                <a:latin typeface="Arial"/>
+              </a:rPr>
+              <a:t>o</a:t>
+            </a:r>
+            <a:r>
+              <a:rPr sz="2800">
+                <a:solidFill>
+                  <a:srgbClr val="323232"/>
+                </a:solidFill>
+                <a:latin typeface="Arial"/>
+              </a:rPr>
+              <a:t>u</a:t>
+            </a:r>
+            <a:r>
+              <a:rPr sz="2800">
+                <a:solidFill>
+                  <a:srgbClr val="323232"/>
+                </a:solidFill>
+                <a:latin typeface="Arial"/>
+              </a:rPr>
+              <a:t>t</a:t>
+            </a:r>
+            <a:r>
+              <a:rPr sz="2800">
+                <a:solidFill>
+                  <a:srgbClr val="323232"/>
+                </a:solidFill>
+                <a:latin typeface="Arial"/>
+              </a:rPr>
+              <a:t>s, ra</a:t>
+            </a:r>
+            <a:r>
+              <a:rPr sz="2800">
+                <a:solidFill>
+                  <a:srgbClr val="323232"/>
+                </a:solidFill>
+                <a:latin typeface="Arial"/>
+              </a:rPr>
+              <a:t>t</a:t>
+            </a:r>
+            <a:r>
+              <a:rPr sz="2800">
+                <a:solidFill>
+                  <a:srgbClr val="323232"/>
+                </a:solidFill>
+                <a:latin typeface="Arial"/>
+              </a:rPr>
+              <a:t>her </a:t>
+            </a:r>
+            <a:r>
+              <a:rPr sz="2800">
+                <a:solidFill>
+                  <a:srgbClr val="323232"/>
+                </a:solidFill>
+                <a:latin typeface="Arial"/>
+              </a:rPr>
+              <a:t>t</a:t>
+            </a:r>
+            <a:r>
+              <a:rPr sz="2800">
+                <a:solidFill>
+                  <a:srgbClr val="323232"/>
+                </a:solidFill>
+                <a:latin typeface="Arial"/>
+              </a:rPr>
+              <a:t>han m</a:t>
+            </a:r>
+            <a:r>
+              <a:rPr sz="2800">
+                <a:solidFill>
+                  <a:srgbClr val="323232"/>
+                </a:solidFill>
+                <a:latin typeface="Arial"/>
+              </a:rPr>
+              <a:t>od</a:t>
+            </a:r>
+            <a:r>
+              <a:rPr sz="2800">
+                <a:solidFill>
+                  <a:srgbClr val="323232"/>
+                </a:solidFill>
+                <a:latin typeface="Arial"/>
+              </a:rPr>
+              <a:t>el ins</a:t>
+            </a:r>
+            <a:r>
+              <a:rPr sz="2800">
+                <a:solidFill>
+                  <a:srgbClr val="323232"/>
+                </a:solidFill>
+                <a:latin typeface="Arial"/>
+              </a:rPr>
+              <a:t>t</a:t>
+            </a:r>
+            <a:r>
+              <a:rPr sz="2800">
+                <a:solidFill>
+                  <a:srgbClr val="323232"/>
+                </a:solidFill>
+                <a:latin typeface="Arial"/>
+              </a:rPr>
+              <a:t>abili</a:t>
+            </a:r>
+            <a:r>
+              <a:rPr sz="2800">
+                <a:solidFill>
+                  <a:srgbClr val="323232"/>
+                </a:solidFill>
+                <a:latin typeface="Arial"/>
+              </a:rPr>
+              <a:t>t</a:t>
+            </a:r>
+            <a:r>
+              <a:rPr sz="2800">
+                <a:solidFill>
+                  <a:srgbClr val="323232"/>
+                </a:solidFill>
+                <a:latin typeface="Arial"/>
+              </a:rPr>
+              <a:t>y. </a:t>
+            </a:r>
+            <a:r>
+              <a:rPr sz="2800" b="1">
+                <a:solidFill>
+                  <a:srgbClr val="1E3A8A"/>
+                </a:solidFill>
+                <a:latin typeface="Arial"/>
+              </a:rPr>
+              <a:t>B</a:t>
+            </a:r>
+            <a:r>
+              <a:rPr sz="2800">
+                <a:solidFill>
+                  <a:srgbClr val="323232"/>
+                </a:solidFill>
+                <a:latin typeface="Arial"/>
+              </a:rPr>
+              <a:t>aseline m</a:t>
+            </a:r>
+            <a:r>
+              <a:rPr sz="2800">
+                <a:solidFill>
+                  <a:srgbClr val="323232"/>
+                </a:solidFill>
+                <a:latin typeface="Arial"/>
+              </a:rPr>
+              <a:t>od</a:t>
+            </a:r>
+            <a:r>
+              <a:rPr sz="2800">
+                <a:solidFill>
+                  <a:srgbClr val="323232"/>
+                </a:solidFill>
+                <a:latin typeface="Arial"/>
+              </a:rPr>
+              <a:t>els like Lay</a:t>
+            </a:r>
+            <a:r>
+              <a:rPr sz="2800">
+                <a:solidFill>
+                  <a:srgbClr val="323232"/>
+                </a:solidFill>
+                <a:latin typeface="Arial"/>
+              </a:rPr>
+              <a:t>o</a:t>
+            </a:r>
+            <a:r>
+              <a:rPr sz="2800">
+                <a:solidFill>
+                  <a:srgbClr val="323232"/>
+                </a:solidFill>
+                <a:latin typeface="Arial"/>
+              </a:rPr>
+              <a:t>u</a:t>
+            </a:r>
+            <a:r>
+              <a:rPr sz="2800">
+                <a:solidFill>
+                  <a:srgbClr val="323232"/>
+                </a:solidFill>
+                <a:latin typeface="Arial"/>
+              </a:rPr>
+              <a:t>t</a:t>
+            </a:r>
+            <a:r>
+              <a:rPr sz="2800">
+                <a:solidFill>
+                  <a:srgbClr val="323232"/>
+                </a:solidFill>
+                <a:latin typeface="Arial"/>
+              </a:rPr>
+              <a:t>LMv3 were </a:t>
+            </a:r>
+            <a:r>
+              <a:rPr sz="2800">
+                <a:solidFill>
+                  <a:srgbClr val="323232"/>
+                </a:solidFill>
+                <a:latin typeface="Arial"/>
+              </a:rPr>
+              <a:t>o</a:t>
+            </a:r>
+            <a:r>
+              <a:rPr sz="2800">
+                <a:solidFill>
+                  <a:srgbClr val="323232"/>
+                </a:solidFill>
+                <a:latin typeface="Arial"/>
+              </a:rPr>
+              <a:t>mi</a:t>
+            </a:r>
+            <a:r>
+              <a:rPr sz="2800">
+                <a:solidFill>
+                  <a:srgbClr val="323232"/>
+                </a:solidFill>
+                <a:latin typeface="Arial"/>
+              </a:rPr>
+              <a:t>tt</a:t>
+            </a:r>
+            <a:r>
+              <a:rPr sz="2800">
+                <a:solidFill>
+                  <a:srgbClr val="323232"/>
+                </a:solidFill>
+                <a:latin typeface="Arial"/>
+              </a:rPr>
+              <a:t>e</a:t>
             </a:r>
             <a:r>
               <a:rPr sz="2800">
@@ -11172,7 +11568,61 @@
                 </a:solidFill>
                 <a:latin typeface="Arial"/>
               </a:rPr>
-              <a:t>e-</a:t>
+              <a:t> </a:t>
+            </a:r>
+            <a:r>
+              <a:rPr sz="2800">
+                <a:solidFill>
+                  <a:srgbClr val="323232"/>
+                </a:solidFill>
+                <a:latin typeface="Arial"/>
+              </a:rPr>
+              <a:t>d</a:t>
+            </a:r>
+            <a:r>
+              <a:rPr sz="2800">
+                <a:solidFill>
+                  <a:srgbClr val="323232"/>
+                </a:solidFill>
+                <a:latin typeface="Arial"/>
+              </a:rPr>
+              <a:t>ue </a:t>
+            </a:r>
+            <a:r>
+              <a:rPr sz="2800">
+                <a:solidFill>
+                  <a:srgbClr val="323232"/>
+                </a:solidFill>
+                <a:latin typeface="Arial"/>
+              </a:rPr>
+              <a:t>to</a:t>
+            </a:r>
+            <a:r>
+              <a:rPr sz="2800">
+                <a:solidFill>
+                  <a:srgbClr val="323232"/>
+                </a:solidFill>
+                <a:latin typeface="Arial"/>
+              </a:rPr>
+              <a:t> la</a:t>
+            </a:r>
+            <a:r>
+              <a:rPr sz="2800">
+                <a:solidFill>
+                  <a:srgbClr val="323232"/>
+                </a:solidFill>
+                <a:latin typeface="Arial"/>
+              </a:rPr>
+              <a:t>c</a:t>
+            </a:r>
+            <a:r>
+              <a:rPr sz="2800">
+                <a:solidFill>
+                  <a:srgbClr val="323232"/>
+                </a:solidFill>
+                <a:latin typeface="Arial"/>
+              </a:rPr>
+              <a:t>k </a:t>
             </a:r>
             <a:r>
               <a:rPr sz="2800">
@@ -11190,25 +11640,25 @@
                 </a:solidFill>
                 <a:latin typeface="Arial"/>
               </a:rPr>
-              <a:t>ffs be</a:t>
-            </a:r>
-            <a:r>
-              <a:rPr sz="2800">
-                <a:solidFill>
-                  <a:srgbClr val="323232"/>
-                </a:solidFill>
-                <a:latin typeface="Arial"/>
-              </a:rPr>
-              <a:t>t</a:t>
-            </a:r>
-            <a:r>
-              <a:rPr sz="2800">
-                <a:solidFill>
-                  <a:srgbClr val="323232"/>
-                </a:solidFill>
-                <a:latin typeface="Arial"/>
-              </a:rPr>
-              <a:t>ween per</a:t>
+              <a:t>f </a:t>
+            </a:r>
+            <a:r>
+              <a:rPr sz="2800">
+                <a:solidFill>
+                  <a:srgbClr val="323232"/>
+                </a:solidFill>
+                <a:latin typeface="Arial"/>
+              </a:rPr>
+              <a:t>t</a:t>
+            </a:r>
+            <a:r>
+              <a:rPr sz="2800">
+                <a:solidFill>
+                  <a:srgbClr val="323232"/>
+                </a:solidFill>
+                <a:latin typeface="Arial"/>
+              </a:rPr>
+              <a:t>ask-spe</a:t>
             </a:r>
             <a:r>
               <a:rPr sz="2800">
@@ -11226,25 +11676,43 @@
                 </a:solidFill>
                 <a:latin typeface="Arial"/>
               </a:rPr>
-              <a:t>ep</a:t>
-            </a:r>
-            <a:r>
-              <a:rPr sz="2800">
-                <a:solidFill>
-                  <a:srgbClr val="323232"/>
-                </a:solidFill>
-                <a:latin typeface="Arial"/>
-              </a:rPr>
-              <a:t>t</a:t>
-            </a:r>
-            <a:r>
-              <a:rPr sz="2800">
-                <a:solidFill>
-                  <a:srgbClr val="323232"/>
-                </a:solidFill>
-                <a:latin typeface="Arial"/>
-              </a:rPr>
-              <a:t>i</a:t>
+              <a:t>ifi</a:t>
+            </a:r>
+            <a:r>
+              <a:rPr sz="2800">
+                <a:solidFill>
+                  <a:srgbClr val="323232"/>
+                </a:solidFill>
+                <a:latin typeface="Arial"/>
+              </a:rPr>
+              <a:t>c</a:t>
+            </a:r>
+            <a:r>
+              <a:rPr sz="2800">
+                <a:solidFill>
+                  <a:srgbClr val="323232"/>
+                </a:solidFill>
+                <a:latin typeface="Arial"/>
+              </a:rPr>
+              <a:t> fine-</a:t>
+            </a:r>
+            <a:r>
+              <a:rPr sz="2800">
+                <a:solidFill>
+                  <a:srgbClr val="323232"/>
+                </a:solidFill>
+                <a:latin typeface="Arial"/>
+              </a:rPr>
+              <a:t>t</a:t>
+            </a:r>
+            <a:r>
+              <a:rPr sz="2800">
+                <a:solidFill>
+                  <a:srgbClr val="323232"/>
+                </a:solidFill>
+                <a:latin typeface="Arial"/>
+              </a:rPr>
+              <a:t>uning res</a:t>
             </a:r>
             <a:r>
               <a:rPr sz="2800">
@@ -11262,277 +11730,25 @@
                 </a:solidFill>
                 <a:latin typeface="Arial"/>
               </a:rPr>
-              <a:t>n m</a:t>
-            </a:r>
-            <a:r>
-              <a:rPr sz="2800">
-                <a:solidFill>
-                  <a:srgbClr val="323232"/>
-                </a:solidFill>
-                <a:latin typeface="Arial"/>
-              </a:rPr>
-              <a:t>od</a:t>
-            </a:r>
-            <a:r>
-              <a:rPr sz="2800">
-                <a:solidFill>
-                  <a:srgbClr val="323232"/>
-                </a:solidFill>
-                <a:latin typeface="Arial"/>
-              </a:rPr>
-              <a:t>ali</a:t>
-            </a:r>
-            <a:r>
-              <a:rPr sz="2800">
-                <a:solidFill>
-                  <a:srgbClr val="323232"/>
-                </a:solidFill>
-                <a:latin typeface="Arial"/>
-              </a:rPr>
-              <a:t>t</a:t>
-            </a:r>
-            <a:r>
-              <a:rPr sz="2800">
-                <a:solidFill>
-                  <a:srgbClr val="323232"/>
-                </a:solidFill>
-                <a:latin typeface="Arial"/>
-              </a:rPr>
-              <a:t>ies, pr</a:t>
-            </a:r>
-            <a:r>
-              <a:rPr sz="2800">
-                <a:solidFill>
-                  <a:srgbClr val="323232"/>
-                </a:solidFill>
-                <a:latin typeface="Arial"/>
-              </a:rPr>
-              <a:t>o</a:t>
-            </a:r>
-            <a:r>
-              <a:rPr sz="2800">
-                <a:solidFill>
-                  <a:srgbClr val="323232"/>
-                </a:solidFill>
-                <a:latin typeface="Arial"/>
-              </a:rPr>
-              <a:t>vi</a:t>
-            </a:r>
-            <a:r>
-              <a:rPr sz="2800">
-                <a:solidFill>
-                  <a:srgbClr val="323232"/>
-                </a:solidFill>
-                <a:latin typeface="Arial"/>
-              </a:rPr>
-              <a:t>d</a:t>
-            </a:r>
-            <a:r>
-              <a:rPr sz="2800">
-                <a:solidFill>
-                  <a:srgbClr val="323232"/>
-                </a:solidFill>
-                <a:latin typeface="Arial"/>
-              </a:rPr>
-              <a:t>ing a verifiable pa</a:t>
-            </a:r>
-            <a:r>
-              <a:rPr sz="2800">
-                <a:solidFill>
-                  <a:srgbClr val="323232"/>
-                </a:solidFill>
-                <a:latin typeface="Arial"/>
-              </a:rPr>
-              <a:t>t</a:t>
-            </a:r>
-            <a:r>
-              <a:rPr sz="2800">
-                <a:solidFill>
-                  <a:srgbClr val="323232"/>
-                </a:solidFill>
-                <a:latin typeface="Arial"/>
-              </a:rPr>
-              <a:t>h f</a:t>
-            </a:r>
-            <a:r>
-              <a:rPr sz="2800">
-                <a:solidFill>
-                  <a:srgbClr val="323232"/>
-                </a:solidFill>
-                <a:latin typeface="Arial"/>
-              </a:rPr>
-              <a:t>o</a:t>
-            </a:r>
-            <a:r>
-              <a:rPr sz="2800">
-                <a:solidFill>
-                  <a:srgbClr val="323232"/>
-                </a:solidFill>
-                <a:latin typeface="Arial"/>
-              </a:rPr>
-              <a:t>rwar</a:t>
-            </a:r>
-            <a:r>
-              <a:rPr sz="2800">
-                <a:solidFill>
-                  <a:srgbClr val="323232"/>
-                </a:solidFill>
-                <a:latin typeface="Arial"/>
-              </a:rPr>
-              <a:t>d</a:t>
-            </a:r>
-            <a:r>
-              <a:rPr sz="2800">
-                <a:solidFill>
-                  <a:srgbClr val="323232"/>
-                </a:solidFill>
-                <a:latin typeface="Arial"/>
-              </a:rPr>
-              <a:t> f</a:t>
-            </a:r>
-            <a:r>
-              <a:rPr sz="2800">
-                <a:solidFill>
-                  <a:srgbClr val="323232"/>
-                </a:solidFill>
-                <a:latin typeface="Arial"/>
-              </a:rPr>
-              <a:t>o</a:t>
-            </a:r>
-            <a:r>
-              <a:rPr sz="2800">
-                <a:solidFill>
-                  <a:srgbClr val="323232"/>
-                </a:solidFill>
-                <a:latin typeface="Arial"/>
-              </a:rPr>
-              <a:t>r r</a:t>
-            </a:r>
-            <a:r>
-              <a:rPr sz="2800">
-                <a:solidFill>
-                  <a:srgbClr val="323232"/>
-                </a:solidFill>
-                <a:latin typeface="Arial"/>
-              </a:rPr>
-              <a:t>o</a:t>
-            </a:r>
-            <a:r>
-              <a:rPr sz="2800">
-                <a:solidFill>
-                  <a:srgbClr val="323232"/>
-                </a:solidFill>
-                <a:latin typeface="Arial"/>
-              </a:rPr>
-              <a:t>bus</a:t>
-            </a:r>
-            <a:r>
-              <a:rPr sz="2800">
-                <a:solidFill>
-                  <a:srgbClr val="323232"/>
-                </a:solidFill>
-                <a:latin typeface="Arial"/>
-              </a:rPr>
-              <a:t>t</a:t>
-            </a:r>
-            <a:r>
-              <a:rPr sz="2800">
-                <a:solidFill>
-                  <a:srgbClr val="323232"/>
-                </a:solidFill>
-                <a:latin typeface="Arial"/>
-              </a:rPr>
-              <a:t> in</a:t>
-            </a:r>
-            <a:r>
-              <a:rPr sz="2800">
-                <a:solidFill>
-                  <a:srgbClr val="323232"/>
-                </a:solidFill>
-                <a:latin typeface="Arial"/>
-              </a:rPr>
-              <a:t>d</a:t>
-            </a:r>
-            <a:r>
-              <a:rPr sz="2800">
-                <a:solidFill>
-                  <a:srgbClr val="323232"/>
-                </a:solidFill>
-                <a:latin typeface="Arial"/>
-              </a:rPr>
-              <a:t>us</a:t>
-            </a:r>
-            <a:r>
-              <a:rPr sz="2800">
-                <a:solidFill>
-                  <a:srgbClr val="323232"/>
-                </a:solidFill>
-                <a:latin typeface="Arial"/>
-              </a:rPr>
-              <a:t>t</a:t>
-            </a:r>
-            <a:r>
-              <a:rPr sz="2800">
-                <a:solidFill>
-                  <a:srgbClr val="323232"/>
-                </a:solidFill>
-                <a:latin typeface="Arial"/>
-              </a:rPr>
-              <a:t>rial D</a:t>
-            </a:r>
-            <a:r>
-              <a:rPr sz="2800">
-                <a:solidFill>
-                  <a:srgbClr val="323232"/>
-                </a:solidFill>
-                <a:latin typeface="Arial"/>
-              </a:rPr>
-              <a:t>oc</a:t>
-            </a:r>
-            <a:r>
-              <a:rPr sz="2800">
-                <a:solidFill>
-                  <a:srgbClr val="323232"/>
-                </a:solidFill>
-                <a:latin typeface="Arial"/>
-              </a:rPr>
-              <a:t>umen</a:t>
-            </a:r>
-            <a:r>
-              <a:rPr sz="2800">
-                <a:solidFill>
-                  <a:srgbClr val="323232"/>
-                </a:solidFill>
-                <a:latin typeface="Arial"/>
-              </a:rPr>
-              <a:t>t</a:t>
-            </a:r>
-            <a:r>
-              <a:rPr sz="2800">
-                <a:solidFill>
-                  <a:srgbClr val="323232"/>
-                </a:solidFill>
-                <a:latin typeface="Arial"/>
-              </a:rPr>
-              <a:t> </a:t>
-            </a:r>
-            <a:r>
-              <a:rPr sz="2800" b="1">
-                <a:solidFill>
-                  <a:srgbClr val="1E3A8A"/>
-                </a:solidFill>
-                <a:latin typeface="Arial"/>
-              </a:rPr>
-              <a:t>A</a:t>
-            </a:r>
-            <a:r>
-              <a:rPr sz="2800">
-                <a:solidFill>
-                  <a:srgbClr val="323232"/>
-                </a:solidFill>
-                <a:latin typeface="Arial"/>
-              </a:rPr>
-              <a:t>I.</a:t>
+              <a:t>ur</a:t>
+            </a:r>
+            <a:r>
+              <a:rPr sz="2800">
+                <a:solidFill>
+                  <a:srgbClr val="323232"/>
+                </a:solidFill>
+                <a:latin typeface="Arial"/>
+              </a:rPr>
+              <a:t>c</a:t>
+            </a:r>
+            <a:r>
+              <a:rPr sz="2800">
+                <a:solidFill>
+                  <a:srgbClr val="323232"/>
+                </a:solidFill>
+                <a:latin typeface="Arial"/>
+              </a:rPr>
+              <a:t>es.</a:t>
             </a:r>
           </a:p>
           <a:p>
@@ -11710,7 +11926,79 @@
                 </a:solidFill>
                 <a:latin typeface="Arial"/>
               </a:rPr>
-              <a:t> asyn</a:t>
+              <a:t> </a:t>
+            </a:r>
+            <a:r>
+              <a:rPr sz="2800">
+                <a:solidFill>
+                  <a:srgbClr val="323232"/>
+                </a:solidFill>
+                <a:latin typeface="Arial"/>
+              </a:rPr>
+              <a:t>t</a:t>
+            </a:r>
+            <a:r>
+              <a:rPr sz="2800">
+                <a:solidFill>
+                  <a:srgbClr val="323232"/>
+                </a:solidFill>
+                <a:latin typeface="Arial"/>
+              </a:rPr>
+              <a:t>ens</a:t>
+            </a:r>
+            <a:r>
+              <a:rPr sz="2800">
+                <a:solidFill>
+                  <a:srgbClr val="323232"/>
+                </a:solidFill>
+                <a:latin typeface="Arial"/>
+              </a:rPr>
+              <a:t>o</a:t>
+            </a:r>
+            <a:r>
+              <a:rPr sz="2800">
+                <a:solidFill>
+                  <a:srgbClr val="323232"/>
+                </a:solidFill>
+                <a:latin typeface="Arial"/>
+              </a:rPr>
+              <a:t>r pr</a:t>
+            </a:r>
+            <a:r>
+              <a:rPr sz="2800">
+                <a:solidFill>
+                  <a:srgbClr val="323232"/>
+                </a:solidFill>
+                <a:latin typeface="Arial"/>
+              </a:rPr>
+              <a:t>oc</a:t>
+            </a:r>
+            <a:r>
+              <a:rPr sz="2800">
+                <a:solidFill>
+                  <a:srgbClr val="323232"/>
+                </a:solidFill>
+                <a:latin typeface="Arial"/>
+              </a:rPr>
+              <a:t>essing an</a:t>
+            </a:r>
+            <a:r>
+              <a:rPr sz="2800">
+                <a:solidFill>
+                  <a:srgbClr val="323232"/>
+                </a:solidFill>
+                <a:latin typeface="Arial"/>
+              </a:rPr>
+              <a:t>d</a:t>
+            </a:r>
+            <a:r>
+              <a:rPr sz="2800">
+                <a:solidFill>
+                  <a:srgbClr val="323232"/>
+                </a:solidFill>
+                <a:latin typeface="Arial"/>
+              </a:rPr>
+              <a:t> s</a:t>
             </a:r>
             <a:r>
               <a:rPr sz="2800">
@@ -11728,7 +12016,25 @@
                 </a:solidFill>
                 <a:latin typeface="Arial"/>
               </a:rPr>
-              <a:t>hr</a:t>
+              <a:t>aling a</a:t>
+            </a:r>
+            <a:r>
+              <a:rPr sz="2800">
+                <a:solidFill>
+                  <a:srgbClr val="323232"/>
+                </a:solidFill>
+                <a:latin typeface="Arial"/>
+              </a:rPr>
+              <a:t>c</a:t>
+            </a:r>
+            <a:r>
+              <a:rPr sz="2800">
+                <a:solidFill>
+                  <a:srgbClr val="323232"/>
+                </a:solidFill>
+                <a:latin typeface="Arial"/>
+              </a:rPr>
+              <a:t>r</a:t>
             </a:r>
             <a:r>
               <a:rPr sz="2800">
@@ -11746,7 +12052,97 @@
                 </a:solidFill>
                 <a:latin typeface="Arial"/>
               </a:rPr>
-              <a:t>n</a:t>
+              <a:t>ss </a:t>
+            </a:r>
+            <a:r>
+              <a:rPr sz="2800">
+                <a:solidFill>
+                  <a:srgbClr val="323232"/>
+                </a:solidFill>
+                <a:latin typeface="Arial"/>
+              </a:rPr>
+              <a:t>d</a:t>
+            </a:r>
+            <a:r>
+              <a:rPr sz="2800">
+                <a:solidFill>
+                  <a:srgbClr val="323232"/>
+                </a:solidFill>
+                <a:latin typeface="Arial"/>
+              </a:rPr>
+              <a:t>ense </a:t>
+            </a:r>
+            <a:r>
+              <a:rPr sz="2800">
+                <a:solidFill>
+                  <a:srgbClr val="323232"/>
+                </a:solidFill>
+                <a:latin typeface="Arial"/>
+              </a:rPr>
+              <a:t>t</a:t>
+            </a:r>
+            <a:r>
+              <a:rPr sz="2800">
+                <a:solidFill>
+                  <a:srgbClr val="323232"/>
+                </a:solidFill>
+                <a:latin typeface="Arial"/>
+              </a:rPr>
+              <a:t>abular-spe</a:t>
+            </a:r>
+            <a:r>
+              <a:rPr sz="2800">
+                <a:solidFill>
+                  <a:srgbClr val="323232"/>
+                </a:solidFill>
+                <a:latin typeface="Arial"/>
+              </a:rPr>
+              <a:t>c</a:t>
+            </a:r>
+            <a:r>
+              <a:rPr sz="2800">
+                <a:solidFill>
+                  <a:srgbClr val="323232"/>
+                </a:solidFill>
+                <a:latin typeface="Arial"/>
+              </a:rPr>
+              <a:t>ifi</a:t>
+            </a:r>
+            <a:r>
+              <a:rPr sz="2800">
+                <a:solidFill>
+                  <a:srgbClr val="323232"/>
+                </a:solidFill>
+                <a:latin typeface="Arial"/>
+              </a:rPr>
+              <a:t>c</a:t>
+            </a:r>
+            <a:r>
+              <a:rPr sz="2800">
+                <a:solidFill>
+                  <a:srgbClr val="323232"/>
+                </a:solidFill>
+                <a:latin typeface="Arial"/>
+              </a:rPr>
+              <a:t> </a:t>
+            </a:r>
+            <a:r>
+              <a:rPr sz="2800">
+                <a:solidFill>
+                  <a:srgbClr val="323232"/>
+                </a:solidFill>
+                <a:latin typeface="Arial"/>
+              </a:rPr>
+              <a:t>co</a:t>
+            </a:r>
+            <a:r>
+              <a:rPr sz="2800">
+                <a:solidFill>
+                  <a:srgbClr val="323232"/>
+                </a:solidFill>
+                <a:latin typeface="Arial"/>
+              </a:rPr>
+              <a:t>rp</a:t>
             </a:r>
             <a:r>
               <a:rPr sz="2800">
@@ -11764,61 +12160,25 @@
                 </a:solidFill>
                 <a:latin typeface="Arial"/>
               </a:rPr>
-              <a:t>us </a:t>
-            </a:r>
-            <a:r>
-              <a:rPr sz="2800">
-                <a:solidFill>
-                  <a:srgbClr val="323232"/>
-                </a:solidFill>
-                <a:latin typeface="Arial"/>
-              </a:rPr>
-              <a:t>t</a:t>
-            </a:r>
-            <a:r>
-              <a:rPr sz="2800">
-                <a:solidFill>
-                  <a:srgbClr val="323232"/>
-                </a:solidFill>
-                <a:latin typeface="Arial"/>
-              </a:rPr>
-              <a:t>ens</a:t>
-            </a:r>
-            <a:r>
-              <a:rPr sz="2800">
-                <a:solidFill>
-                  <a:srgbClr val="323232"/>
-                </a:solidFill>
-                <a:latin typeface="Arial"/>
-              </a:rPr>
-              <a:t>o</a:t>
-            </a:r>
-            <a:r>
-              <a:rPr sz="2800">
-                <a:solidFill>
-                  <a:srgbClr val="323232"/>
-                </a:solidFill>
-                <a:latin typeface="Arial"/>
-              </a:rPr>
-              <a:t>r pr</a:t>
-            </a:r>
-            <a:r>
-              <a:rPr sz="2800">
-                <a:solidFill>
-                  <a:srgbClr val="323232"/>
-                </a:solidFill>
-                <a:latin typeface="Arial"/>
-              </a:rPr>
-              <a:t>oc</a:t>
-            </a:r>
-            <a:r>
-              <a:rPr sz="2800">
-                <a:solidFill>
-                  <a:srgbClr val="323232"/>
-                </a:solidFill>
-                <a:latin typeface="Arial"/>
-              </a:rPr>
-              <a:t>essing.</a:t>
+              <a:t>ra (e.g., TabFa</a:t>
+            </a:r>
+            <a:r>
+              <a:rPr sz="2800">
+                <a:solidFill>
+                  <a:srgbClr val="323232"/>
+                </a:solidFill>
+                <a:latin typeface="Arial"/>
+              </a:rPr>
+              <a:t>ct</a:t>
+            </a:r>
+            <a:r>
+              <a:rPr sz="2800">
+                <a:solidFill>
+                  <a:srgbClr val="323232"/>
+                </a:solidFill>
+                <a:latin typeface="Arial"/>
+              </a:rPr>
+              <a:t>).</a:t>
             </a:r>
           </a:p>
         </p:txBody>

</xml_diff>